<commit_message>
Add reproducible retask benchmark and measured scale results
`python -m sarthi.benchmark --retask [--scale k]` fogs the busiest base
05:00-09:30 (known at 02:00) and compares the minimal-disruption retask
with a naive re-plan; every result is checked by the validator. Over 8
scenarios (~36 missions): 14.5 vs 49.5 aircraft reassigned (-71%) in
2.8 s, fulfilment 96.5% -> 95.6%. These replace the older ad-hoc figures
(12.8 vs 37.5) in the plan, the deck and the demo video's end card.

Scale, on 4 CPUs: ~70 missions plan in 20 s, 10 pts better than greedy,
and retask in ~12 s; at ~104 missions the fleet is saturated and the
advantage narrows. A first two-stage LNS retask (hold every undisturbed
mission, then polish) was tried and not adopted: it saved no time at 70
missions and lost fulfilment. The plan records why and what comes next.

Co-Authored-By: Claude Opus 5.5 <noreply@anthropic.com>
Claude-Session: https://claude.ai/code/session_01UAkYHA1fRCXYtSgq8fkKuR
</commit_message>
<xml_diff>
--- a/docs/VAYU-SARTHI_SIH2026_idea.pptx
+++ b/docs/VAYU-SARTHI_SIH2026_idea.pptx
@@ -4182,7 +4182,7 @@
                 </a:solidFill>
                 <a:latin typeface="Arial"/>
               </a:rPr>
-              <a:t>−66%</a:t>
+              <a:t>−71%</a:t>
             </a:r>
           </a:p>
         </p:txBody>
@@ -4748,7 +4748,7 @@
                 </a:solidFill>
                 <a:latin typeface="Arial"/>
               </a:rPr>
-              <a:t>churn-penalised re-optimisation; launched missions frozen; 12.8 vs 37.5 aircraft reassigned for a fogged base, in 1.7 s.</a:t>
+              <a:t>churn-penalised re-optimisation; launched missions frozen; 14.5 vs 49.5 aircraft reassigned for a fogged base, in 2.8 s.</a:t>
             </a:r>
           </a:p>
           <a:p>
@@ -7891,7 +7891,7 @@
                           </a:solidFill>
                           <a:latin typeface="Arial"/>
                         </a:rPr>
-                        <a:t>37.5 naive re-plan</a:t>
+                        <a:t>49.5 naive re-plan</a:t>
                       </a:r>
                     </a:p>
                   </a:txBody>
@@ -7913,7 +7913,7 @@
                           </a:solidFill>
                           <a:latin typeface="Arial"/>
                         </a:rPr>
-                        <a:t>12.8 in 1.7 s</a:t>
+                        <a:t>14.5 in 2.8 s</a:t>
                       </a:r>
                     </a:p>
                   </a:txBody>

</xml_diff>

<commit_message>
Deck: demo-video link line on the title slide
Co-Authored-By: Claude Opus 5.5 <noreply@anthropic.com>
Claude-Session: https://claude.ai/code/session_01UAkYHA1fRCXYtSgq8fkKuR
</commit_message>
<xml_diff>
--- a/docs/VAYU-SARTHI_SIH2026_idea.pptx
+++ b/docs/VAYU-SARTHI_SIH2026_idea.pptx
@@ -3321,7 +3321,7 @@
         </p:nvSpPr>
         <p:spPr>
           <a:xfrm>
-            <a:off x="548640" y="2926080"/>
+            <a:off x="548640" y="2788920"/>
             <a:ext cx="2103120" cy="365760"/>
           </a:xfrm>
           <a:prstGeom prst="rect">
@@ -3363,7 +3363,7 @@
         </p:nvSpPr>
         <p:spPr>
           <a:xfrm>
-            <a:off x="2651760" y="2926080"/>
+            <a:off x="2651760" y="2788920"/>
             <a:ext cx="3840480" cy="365760"/>
           </a:xfrm>
           <a:prstGeom prst="rect">
@@ -3405,7 +3405,7 @@
         </p:nvSpPr>
         <p:spPr>
           <a:xfrm>
-            <a:off x="548640" y="3291840"/>
+            <a:off x="548640" y="3154679"/>
             <a:ext cx="2103120" cy="566928"/>
           </a:xfrm>
           <a:prstGeom prst="rect">
@@ -3447,7 +3447,7 @@
         </p:nvSpPr>
         <p:spPr>
           <a:xfrm>
-            <a:off x="2651760" y="3291840"/>
+            <a:off x="2651760" y="3154679"/>
             <a:ext cx="3840480" cy="566928"/>
           </a:xfrm>
           <a:prstGeom prst="rect">
@@ -3489,7 +3489,7 @@
         </p:nvSpPr>
         <p:spPr>
           <a:xfrm>
-            <a:off x="548640" y="3858768"/>
+            <a:off x="548640" y="3721607"/>
             <a:ext cx="2103120" cy="566928"/>
           </a:xfrm>
           <a:prstGeom prst="rect">
@@ -3531,7 +3531,7 @@
         </p:nvSpPr>
         <p:spPr>
           <a:xfrm>
-            <a:off x="2651760" y="3858768"/>
+            <a:off x="2651760" y="3721607"/>
             <a:ext cx="3840480" cy="566928"/>
           </a:xfrm>
           <a:prstGeom prst="rect">
@@ -3573,7 +3573,7 @@
         </p:nvSpPr>
         <p:spPr>
           <a:xfrm>
-            <a:off x="548640" y="4425696"/>
+            <a:off x="548640" y="4288536"/>
             <a:ext cx="2103120" cy="365760"/>
           </a:xfrm>
           <a:prstGeom prst="rect">
@@ -3615,7 +3615,7 @@
         </p:nvSpPr>
         <p:spPr>
           <a:xfrm>
-            <a:off x="2651760" y="4425696"/>
+            <a:off x="2651760" y="4288536"/>
             <a:ext cx="3840480" cy="365760"/>
           </a:xfrm>
           <a:prstGeom prst="rect">
@@ -3657,7 +3657,7 @@
         </p:nvSpPr>
         <p:spPr>
           <a:xfrm>
-            <a:off x="548640" y="4791456"/>
+            <a:off x="548640" y="4654296"/>
             <a:ext cx="2103120" cy="365760"/>
           </a:xfrm>
           <a:prstGeom prst="rect">
@@ -3699,7 +3699,7 @@
         </p:nvSpPr>
         <p:spPr>
           <a:xfrm>
-            <a:off x="2651760" y="4791456"/>
+            <a:off x="2651760" y="4654296"/>
             <a:ext cx="3840480" cy="365760"/>
           </a:xfrm>
           <a:prstGeom prst="rect">
@@ -3741,7 +3741,7 @@
         </p:nvSpPr>
         <p:spPr>
           <a:xfrm>
-            <a:off x="548640" y="5157216"/>
+            <a:off x="548640" y="5020056"/>
             <a:ext cx="2103120" cy="365760"/>
           </a:xfrm>
           <a:prstGeom prst="rect">
@@ -3783,7 +3783,7 @@
         </p:nvSpPr>
         <p:spPr>
           <a:xfrm>
-            <a:off x="2651760" y="5157216"/>
+            <a:off x="2651760" y="5020056"/>
             <a:ext cx="3840480" cy="365760"/>
           </a:xfrm>
           <a:prstGeom prst="rect">
@@ -3825,7 +3825,7 @@
         </p:nvSpPr>
         <p:spPr>
           <a:xfrm>
-            <a:off x="548640" y="5522976"/>
+            <a:off x="548640" y="5385816"/>
             <a:ext cx="2103120" cy="365760"/>
           </a:xfrm>
           <a:prstGeom prst="rect">
@@ -3867,7 +3867,7 @@
         </p:nvSpPr>
         <p:spPr>
           <a:xfrm>
-            <a:off x="2651760" y="5522976"/>
+            <a:off x="2651760" y="5385816"/>
             <a:ext cx="3840480" cy="365760"/>
           </a:xfrm>
           <a:prstGeom prst="rect">
@@ -3901,9 +3901,93 @@
           </a:p>
         </p:txBody>
       </p:sp>
+      <p:sp>
+        <p:nvSpPr>
+          <p:cNvPr id="21" name="TextBox 20"/>
+          <p:cNvSpPr txBox="1"/>
+          <p:nvPr/>
+        </p:nvSpPr>
+        <p:spPr>
+          <a:xfrm>
+            <a:off x="548640" y="5751576"/>
+            <a:ext cx="2103120" cy="365760"/>
+          </a:xfrm>
+          <a:prstGeom prst="rect">
+            <a:avLst/>
+          </a:prstGeom>
+          <a:noFill/>
+        </p:spPr>
+        <p:txBody>
+          <a:bodyPr wrap="square" lIns="18288" rIns="18288" tIns="18288" bIns="18288" anchor="t">
+            <a:spAutoFit/>
+          </a:bodyPr>
+          <a:lstStyle/>
+          <a:p>
+            <a:pPr algn="l">
+              <a:lnSpc>
+                <a:spcPct val="110000"/>
+              </a:lnSpc>
+              <a:spcAft>
+                <a:spcPts val="400"/>
+              </a:spcAft>
+            </a:pPr>
+            <a:r>
+              <a:rPr sz="1200" b="0" i="0">
+                <a:solidFill>
+                  <a:srgbClr val="898781"/>
+                </a:solidFill>
+                <a:latin typeface="Arial"/>
+              </a:rPr>
+              <a:t>Demo video</a:t>
+            </a:r>
+          </a:p>
+        </p:txBody>
+      </p:sp>
+      <p:sp>
+        <p:nvSpPr>
+          <p:cNvPr id="22" name="TextBox 21"/>
+          <p:cNvSpPr txBox="1"/>
+          <p:nvPr/>
+        </p:nvSpPr>
+        <p:spPr>
+          <a:xfrm>
+            <a:off x="2651760" y="5751576"/>
+            <a:ext cx="3840480" cy="365760"/>
+          </a:xfrm>
+          <a:prstGeom prst="rect">
+            <a:avLst/>
+          </a:prstGeom>
+          <a:noFill/>
+        </p:spPr>
+        <p:txBody>
+          <a:bodyPr wrap="square" lIns="18288" rIns="18288" tIns="18288" bIns="18288" anchor="t">
+            <a:spAutoFit/>
+          </a:bodyPr>
+          <a:lstStyle/>
+          <a:p>
+            <a:pPr algn="l">
+              <a:lnSpc>
+                <a:spcPct val="110000"/>
+              </a:lnSpc>
+              <a:spcAft>
+                <a:spcPts val="400"/>
+              </a:spcAft>
+            </a:pPr>
+            <a:r>
+              <a:rPr sz="1300" b="1" i="0">
+                <a:solidFill>
+                  <a:srgbClr val="FFFFFF"/>
+                </a:solidFill>
+                <a:latin typeface="Arial"/>
+              </a:rPr>
+              <a:t>________</a:t>
+            </a:r>
+          </a:p>
+        </p:txBody>
+      </p:sp>
       <p:pic>
         <p:nvPicPr>
-          <p:cNvPr id="21" name="Picture 20" descr="01-plan.png"/>
+          <p:cNvPr id="23" name="Picture 22" descr="01-plan.png"/>
           <p:cNvPicPr>
             <a:picLocks noChangeAspect="1"/>
           </p:cNvPicPr>
@@ -3933,7 +4017,7 @@
       </p:pic>
       <p:sp>
         <p:nvSpPr>
-          <p:cNvPr id="22" name="TextBox 21"/>
+          <p:cNvPr id="24" name="TextBox 23"/>
           <p:cNvSpPr txBox="1"/>
           <p:nvPr/>
         </p:nvSpPr>
@@ -3975,7 +4059,7 @@
       </p:sp>
       <p:sp>
         <p:nvSpPr>
-          <p:cNvPr id="23" name="Rounded Rectangle 22"/>
+          <p:cNvPr id="25" name="Rounded Rectangle 24"/>
           <p:cNvSpPr/>
           <p:nvPr/>
         </p:nvSpPr>
@@ -4021,7 +4105,7 @@
       </p:sp>
       <p:sp>
         <p:nvSpPr>
-          <p:cNvPr id="24" name="TextBox 23"/>
+          <p:cNvPr id="26" name="TextBox 25"/>
           <p:cNvSpPr txBox="1"/>
           <p:nvPr/>
         </p:nvSpPr>
@@ -4063,7 +4147,7 @@
       </p:sp>
       <p:sp>
         <p:nvSpPr>
-          <p:cNvPr id="25" name="TextBox 24"/>
+          <p:cNvPr id="27" name="TextBox 26"/>
           <p:cNvSpPr txBox="1"/>
           <p:nvPr/>
         </p:nvSpPr>
@@ -4105,7 +4189,7 @@
       </p:sp>
       <p:sp>
         <p:nvSpPr>
-          <p:cNvPr id="26" name="TextBox 25"/>
+          <p:cNvPr id="28" name="TextBox 27"/>
           <p:cNvSpPr txBox="1"/>
           <p:nvPr/>
         </p:nvSpPr>
@@ -4147,7 +4231,7 @@
       </p:sp>
       <p:sp>
         <p:nvSpPr>
-          <p:cNvPr id="27" name="TextBox 26"/>
+          <p:cNvPr id="29" name="TextBox 28"/>
           <p:cNvSpPr txBox="1"/>
           <p:nvPr/>
         </p:nvSpPr>
@@ -4189,7 +4273,7 @@
       </p:sp>
       <p:sp>
         <p:nvSpPr>
-          <p:cNvPr id="28" name="TextBox 27"/>
+          <p:cNvPr id="30" name="TextBox 29"/>
           <p:cNvSpPr txBox="1"/>
           <p:nvPr/>
         </p:nvSpPr>
@@ -4231,7 +4315,7 @@
       </p:sp>
       <p:sp>
         <p:nvSpPr>
-          <p:cNvPr id="29" name="TextBox 28"/>
+          <p:cNvPr id="31" name="TextBox 30"/>
           <p:cNvSpPr txBox="1"/>
           <p:nvPr/>
         </p:nvSpPr>
@@ -4273,7 +4357,7 @@
       </p:sp>
       <p:sp>
         <p:nvSpPr>
-          <p:cNvPr id="30" name="TextBox 29"/>
+          <p:cNvPr id="32" name="TextBox 31"/>
           <p:cNvSpPr txBox="1"/>
           <p:nvPr/>
         </p:nvSpPr>

</xml_diff>